<commit_message>
Annotate summary slides with which paper each technology appears in
- EHR-data slide: add a '出現於哪幾篇' column mapping each signal-acquisition
  method to paper numbers (HR/SpO2 -> 1·2·3·5, RR -> 1, temp -> 1·3, BP -> 2,
  cough -> 3, clinical obs -> 1·2), plus a note that Joseph reuses existing EHR
- Integration-methods slide: label each method with its source paper number

Co-Authored-By: Claude Opus 4.8 <noreply@anthropic.com>
Claude-Session: https://claude.ai/code/session_01CFRiU1zo6fRgreoXqaJ1e6
</commit_message>
<xml_diff>
--- a/ppt/低成本設備輔助檢傷_報告版.pptx
+++ b/ppt/低成本設備輔助檢傷_報告版.pptx
@@ -11847,7 +11847,7 @@
         </p:nvSpPr>
         <p:spPr>
           <a:xfrm>
-            <a:off x="713232" y="1234440"/>
+            <a:off x="713232" y="1207008"/>
             <a:ext cx="10744200" cy="365760"/>
           </a:xfrm>
           <a:prstGeom prst="rect">
@@ -11882,7 +11882,7 @@
                 <a:ea typeface="Microsoft JhengHei"/>
                 <a:cs typeface="Microsoft JhengHei"/>
               </a:rPr>
-              <a:t>這些正對應 EHR 裡的「生命徵象 / 臨床觀察」欄位。成熟度：綠=可靠　黃=篩檢級/研究中　紅=仍受限。</a:t>
+              <a:t>每列＝ EHR 項目 ｜ 便宜取得方式 ｜ 出現於哪幾篇 ｜ 成熟度（綠=可靠　黃=篩檢/研究　紅=受限）</a:t>
             </a:r>
           </a:p>
         </p:txBody>
@@ -11895,8 +11895,8 @@
         </p:nvSpPr>
         <p:spPr>
           <a:xfrm>
-            <a:off x="713232" y="1737360"/>
-            <a:ext cx="10744200" cy="512064"/>
+            <a:off x="713232" y="1700784"/>
+            <a:ext cx="10744200" cy="493776"/>
           </a:xfrm>
           <a:prstGeom prst="roundRect">
             <a:avLst>
@@ -11941,8 +11941,8 @@
         </p:nvSpPr>
         <p:spPr>
           <a:xfrm>
-            <a:off x="713232" y="1737360"/>
-            <a:ext cx="82296" cy="512064"/>
+            <a:off x="713232" y="1700784"/>
+            <a:ext cx="82296" cy="493776"/>
           </a:xfrm>
           <a:prstGeom prst="rect">
             <a:avLst/>
@@ -11985,8 +11985,8 @@
         </p:nvSpPr>
         <p:spPr>
           <a:xfrm>
-            <a:off x="914400" y="1792224"/>
-            <a:ext cx="2834640" cy="420624"/>
+            <a:off x="914400" y="1746504"/>
+            <a:ext cx="2697480" cy="420624"/>
           </a:xfrm>
           <a:prstGeom prst="rect">
             <a:avLst/>
@@ -12012,7 +12012,7 @@
               <a:buNone/>
             </a:pPr>
             <a:r>
-              <a:rPr sz="1250" b="1" i="0" lang="zh-TW">
+              <a:rPr sz="1200" b="1" i="0" lang="zh-TW">
                 <a:solidFill>
                   <a:srgbClr val="162433"/>
                 </a:solidFill>
@@ -12033,8 +12033,8 @@
         </p:nvSpPr>
         <p:spPr>
           <a:xfrm>
-            <a:off x="3794760" y="1792224"/>
-            <a:ext cx="5852160" cy="420624"/>
+            <a:off x="3657600" y="1746504"/>
+            <a:ext cx="4480560" cy="420624"/>
           </a:xfrm>
           <a:prstGeom prst="rect">
             <a:avLst/>
@@ -12060,7 +12060,7 @@
               <a:buNone/>
             </a:pPr>
             <a:r>
-              <a:rPr sz="1100" b="0" i="0" lang="zh-TW">
+              <a:rPr sz="1050" b="0" i="0" lang="zh-TW">
                 <a:solidFill>
                   <a:srgbClr val="33414F"/>
                 </a:solidFill>
@@ -12075,13 +12075,61 @@
       </p:sp>
       <p:sp>
         <p:nvSpPr>
-          <p:cNvPr id="10" name="Rounded Rectangle 9"/>
+          <p:cNvPr id="10" name="TextBox 9"/>
+          <p:cNvSpPr txBox="1"/>
+          <p:nvPr/>
+        </p:nvSpPr>
+        <p:spPr>
+          <a:xfrm>
+            <a:off x="8211312" y="1746504"/>
+            <a:ext cx="1783080" cy="420624"/>
+          </a:xfrm>
+          <a:prstGeom prst="rect">
+            <a:avLst/>
+          </a:prstGeom>
+          <a:noFill/>
+        </p:spPr>
+        <p:txBody>
+          <a:bodyPr wrap="square" anchor="ctr" lIns="0" rIns="0" tIns="0" bIns="0">
+            <a:spAutoFit/>
+          </a:bodyPr>
+          <a:lstStyle/>
+          <a:p>
+            <a:pPr algn="l">
+              <a:lnSpc>
+                <a:spcPct val="100000"/>
+              </a:lnSpc>
+              <a:spcBef>
+                <a:spcPts val="0"/>
+              </a:spcBef>
+              <a:spcAft>
+                <a:spcPts val="400"/>
+              </a:spcAft>
+              <a:buNone/>
+            </a:pPr>
+            <a:r>
+              <a:rPr sz="1050" b="1" i="0" lang="zh-TW">
+                <a:solidFill>
+                  <a:srgbClr val="1F9EB3"/>
+                </a:solidFill>
+                <a:latin typeface="Segoe UI"/>
+                <a:ea typeface="Microsoft JhengHei"/>
+                <a:cs typeface="Microsoft JhengHei"/>
+              </a:rPr>
+              <a:t>論文 1·2·3·5</a:t>
+            </a:r>
+          </a:p>
+        </p:txBody>
+      </p:sp>
+      <p:sp>
+        <p:nvSpPr>
+          <p:cNvPr id="11" name="Rounded Rectangle 10"/>
           <p:cNvSpPr/>
           <p:nvPr/>
         </p:nvSpPr>
         <p:spPr>
           <a:xfrm>
-            <a:off x="10698099" y="1828800"/>
+            <a:off x="10698099" y="1783080"/>
             <a:ext cx="658749" cy="329184"/>
           </a:xfrm>
           <a:prstGeom prst="roundRect">
@@ -12143,14 +12191,14 @@
       </p:sp>
       <p:sp>
         <p:nvSpPr>
-          <p:cNvPr id="11" name="Rounded Rectangle 10"/>
+          <p:cNvPr id="12" name="Rounded Rectangle 11"/>
           <p:cNvSpPr/>
           <p:nvPr/>
         </p:nvSpPr>
         <p:spPr>
           <a:xfrm>
-            <a:off x="713232" y="2340864"/>
-            <a:ext cx="10744200" cy="512064"/>
+            <a:off x="713232" y="2286000"/>
+            <a:ext cx="10744200" cy="493776"/>
           </a:xfrm>
           <a:prstGeom prst="roundRect">
             <a:avLst>
@@ -12189,14 +12237,14 @@
       </p:sp>
       <p:sp>
         <p:nvSpPr>
-          <p:cNvPr id="12" name="Rectangle 11"/>
+          <p:cNvPr id="13" name="Rectangle 12"/>
           <p:cNvSpPr/>
           <p:nvPr/>
         </p:nvSpPr>
         <p:spPr>
           <a:xfrm>
-            <a:off x="713232" y="2340864"/>
-            <a:ext cx="82296" cy="512064"/>
+            <a:off x="713232" y="2286000"/>
+            <a:ext cx="82296" cy="493776"/>
           </a:xfrm>
           <a:prstGeom prst="rect">
             <a:avLst/>
@@ -12233,14 +12281,14 @@
       </p:sp>
       <p:sp>
         <p:nvSpPr>
-          <p:cNvPr id="13" name="TextBox 12"/>
+          <p:cNvPr id="14" name="TextBox 13"/>
           <p:cNvSpPr txBox="1"/>
           <p:nvPr/>
         </p:nvSpPr>
         <p:spPr>
           <a:xfrm>
-            <a:off x="914400" y="2395728"/>
-            <a:ext cx="2834640" cy="420624"/>
+            <a:off x="914400" y="2331720"/>
+            <a:ext cx="2697480" cy="420624"/>
           </a:xfrm>
           <a:prstGeom prst="rect">
             <a:avLst/>
@@ -12266,7 +12314,7 @@
               <a:buNone/>
             </a:pPr>
             <a:r>
-              <a:rPr sz="1250" b="1" i="0" lang="zh-TW">
+              <a:rPr sz="1200" b="1" i="0" lang="zh-TW">
                 <a:solidFill>
                   <a:srgbClr val="162433"/>
                 </a:solidFill>
@@ -12281,14 +12329,14 @@
       </p:sp>
       <p:sp>
         <p:nvSpPr>
-          <p:cNvPr id="14" name="TextBox 13"/>
+          <p:cNvPr id="15" name="TextBox 14"/>
           <p:cNvSpPr txBox="1"/>
           <p:nvPr/>
         </p:nvSpPr>
         <p:spPr>
           <a:xfrm>
-            <a:off x="3794760" y="2395728"/>
-            <a:ext cx="5852160" cy="420624"/>
+            <a:off x="3657600" y="2331720"/>
+            <a:ext cx="4480560" cy="420624"/>
           </a:xfrm>
           <a:prstGeom prst="rect">
             <a:avLst/>
@@ -12314,7 +12362,7 @@
               <a:buNone/>
             </a:pPr>
             <a:r>
-              <a:rPr sz="1100" b="0" i="0" lang="zh-TW">
+              <a:rPr sz="1050" b="0" i="0" lang="zh-TW">
                 <a:solidFill>
                   <a:srgbClr val="33414F"/>
                 </a:solidFill>
@@ -12322,20 +12370,68 @@
                 <a:ea typeface="Microsoft JhengHei"/>
                 <a:cs typeface="Microsoft JhengHei"/>
               </a:rPr>
-              <a:t>夾式血氧計(準) · 手機相機＋閃光(篩檢級)</a:t>
-            </a:r>
-          </a:p>
-        </p:txBody>
-      </p:sp>
-      <p:sp>
-        <p:nvSpPr>
-          <p:cNvPr id="15" name="Rounded Rectangle 14"/>
+              <a:t>夾式/插入式血氧計(準) · 手機相機＋閃光(篩檢級)</a:t>
+            </a:r>
+          </a:p>
+        </p:txBody>
+      </p:sp>
+      <p:sp>
+        <p:nvSpPr>
+          <p:cNvPr id="16" name="TextBox 15"/>
+          <p:cNvSpPr txBox="1"/>
+          <p:nvPr/>
+        </p:nvSpPr>
+        <p:spPr>
+          <a:xfrm>
+            <a:off x="8211312" y="2331720"/>
+            <a:ext cx="1783080" cy="420624"/>
+          </a:xfrm>
+          <a:prstGeom prst="rect">
+            <a:avLst/>
+          </a:prstGeom>
+          <a:noFill/>
+        </p:spPr>
+        <p:txBody>
+          <a:bodyPr wrap="square" anchor="ctr" lIns="0" rIns="0" tIns="0" bIns="0">
+            <a:spAutoFit/>
+          </a:bodyPr>
+          <a:lstStyle/>
+          <a:p>
+            <a:pPr algn="l">
+              <a:lnSpc>
+                <a:spcPct val="100000"/>
+              </a:lnSpc>
+              <a:spcBef>
+                <a:spcPts val="0"/>
+              </a:spcBef>
+              <a:spcAft>
+                <a:spcPts val="400"/>
+              </a:spcAft>
+              <a:buNone/>
+            </a:pPr>
+            <a:r>
+              <a:rPr sz="1050" b="1" i="0" lang="zh-TW">
+                <a:solidFill>
+                  <a:srgbClr val="1F9EB3"/>
+                </a:solidFill>
+                <a:latin typeface="Segoe UI"/>
+                <a:ea typeface="Microsoft JhengHei"/>
+                <a:cs typeface="Microsoft JhengHei"/>
+              </a:rPr>
+              <a:t>論文 1·2·3·5</a:t>
+            </a:r>
+          </a:p>
+        </p:txBody>
+      </p:sp>
+      <p:sp>
+        <p:nvSpPr>
+          <p:cNvPr id="17" name="Rounded Rectangle 16"/>
           <p:cNvSpPr/>
           <p:nvPr/>
         </p:nvSpPr>
         <p:spPr>
           <a:xfrm>
-            <a:off x="10203371" y="2432304"/>
+            <a:off x="10203371" y="2368296"/>
             <a:ext cx="1153477" cy="329184"/>
           </a:xfrm>
           <a:prstGeom prst="roundRect">
@@ -12397,14 +12493,14 @@
       </p:sp>
       <p:sp>
         <p:nvSpPr>
-          <p:cNvPr id="16" name="Rounded Rectangle 15"/>
+          <p:cNvPr id="18" name="Rounded Rectangle 17"/>
           <p:cNvSpPr/>
           <p:nvPr/>
         </p:nvSpPr>
         <p:spPr>
           <a:xfrm>
-            <a:off x="713232" y="2944368"/>
-            <a:ext cx="10744200" cy="512064"/>
+            <a:off x="713232" y="2871216"/>
+            <a:ext cx="10744200" cy="493776"/>
           </a:xfrm>
           <a:prstGeom prst="roundRect">
             <a:avLst>
@@ -12443,14 +12539,14 @@
       </p:sp>
       <p:sp>
         <p:nvSpPr>
-          <p:cNvPr id="17" name="Rectangle 16"/>
+          <p:cNvPr id="19" name="Rectangle 18"/>
           <p:cNvSpPr/>
           <p:nvPr/>
         </p:nvSpPr>
         <p:spPr>
           <a:xfrm>
-            <a:off x="713232" y="2944368"/>
-            <a:ext cx="82296" cy="512064"/>
+            <a:off x="713232" y="2871216"/>
+            <a:ext cx="82296" cy="493776"/>
           </a:xfrm>
           <a:prstGeom prst="rect">
             <a:avLst/>
@@ -12487,14 +12583,14 @@
       </p:sp>
       <p:sp>
         <p:nvSpPr>
-          <p:cNvPr id="18" name="TextBox 17"/>
+          <p:cNvPr id="20" name="TextBox 19"/>
           <p:cNvSpPr txBox="1"/>
           <p:nvPr/>
         </p:nvSpPr>
         <p:spPr>
           <a:xfrm>
-            <a:off x="914400" y="2999232"/>
-            <a:ext cx="2834640" cy="420624"/>
+            <a:off x="914400" y="2916936"/>
+            <a:ext cx="2697480" cy="420624"/>
           </a:xfrm>
           <a:prstGeom prst="rect">
             <a:avLst/>
@@ -12520,7 +12616,7 @@
               <a:buNone/>
             </a:pPr>
             <a:r>
-              <a:rPr sz="1250" b="1" i="0" lang="zh-TW">
+              <a:rPr sz="1200" b="1" i="0" lang="zh-TW">
                 <a:solidFill>
                   <a:srgbClr val="162433"/>
                 </a:solidFill>
@@ -12535,14 +12631,14 @@
       </p:sp>
       <p:sp>
         <p:nvSpPr>
-          <p:cNvPr id="19" name="TextBox 18"/>
+          <p:cNvPr id="21" name="TextBox 20"/>
           <p:cNvSpPr txBox="1"/>
           <p:nvPr/>
         </p:nvSpPr>
         <p:spPr>
           <a:xfrm>
-            <a:off x="3794760" y="2999232"/>
-            <a:ext cx="5852160" cy="420624"/>
+            <a:off x="3657600" y="2916936"/>
+            <a:ext cx="4480560" cy="420624"/>
           </a:xfrm>
           <a:prstGeom prst="rect">
             <a:avLst/>
@@ -12568,7 +12664,7 @@
               <a:buNone/>
             </a:pPr>
             <a:r>
-              <a:rPr sz="1100" b="0" i="0" lang="zh-TW">
+              <a:rPr sz="1050" b="0" i="0" lang="zh-TW">
                 <a:solidFill>
                   <a:srgbClr val="33414F"/>
                 </a:solidFill>
@@ -12583,13 +12679,61 @@
       </p:sp>
       <p:sp>
         <p:nvSpPr>
-          <p:cNvPr id="20" name="Rounded Rectangle 19"/>
+          <p:cNvPr id="22" name="TextBox 21"/>
+          <p:cNvSpPr txBox="1"/>
+          <p:nvPr/>
+        </p:nvSpPr>
+        <p:spPr>
+          <a:xfrm>
+            <a:off x="8211312" y="2916936"/>
+            <a:ext cx="1783080" cy="420624"/>
+          </a:xfrm>
+          <a:prstGeom prst="rect">
+            <a:avLst/>
+          </a:prstGeom>
+          <a:noFill/>
+        </p:spPr>
+        <p:txBody>
+          <a:bodyPr wrap="square" anchor="ctr" lIns="0" rIns="0" tIns="0" bIns="0">
+            <a:spAutoFit/>
+          </a:bodyPr>
+          <a:lstStyle/>
+          <a:p>
+            <a:pPr algn="l">
+              <a:lnSpc>
+                <a:spcPct val="100000"/>
+              </a:lnSpc>
+              <a:spcBef>
+                <a:spcPts val="0"/>
+              </a:spcBef>
+              <a:spcAft>
+                <a:spcPts val="400"/>
+              </a:spcAft>
+              <a:buNone/>
+            </a:pPr>
+            <a:r>
+              <a:rPr sz="1050" b="1" i="0" lang="zh-TW">
+                <a:solidFill>
+                  <a:srgbClr val="1F9EB3"/>
+                </a:solidFill>
+                <a:latin typeface="Segoe UI"/>
+                <a:ea typeface="Microsoft JhengHei"/>
+                <a:cs typeface="Microsoft JhengHei"/>
+              </a:rPr>
+              <a:t>論文 1</a:t>
+            </a:r>
+          </a:p>
+        </p:txBody>
+      </p:sp>
+      <p:sp>
+        <p:nvSpPr>
+          <p:cNvPr id="23" name="Rounded Rectangle 22"/>
           <p:cNvSpPr/>
           <p:nvPr/>
         </p:nvSpPr>
         <p:spPr>
           <a:xfrm>
-            <a:off x="10560749" y="3035808"/>
+            <a:off x="10560749" y="2953512"/>
             <a:ext cx="796099" cy="329184"/>
           </a:xfrm>
           <a:prstGeom prst="roundRect">
@@ -12651,14 +12795,14 @@
       </p:sp>
       <p:sp>
         <p:nvSpPr>
-          <p:cNvPr id="21" name="Rounded Rectangle 20"/>
+          <p:cNvPr id="24" name="Rounded Rectangle 23"/>
           <p:cNvSpPr/>
           <p:nvPr/>
         </p:nvSpPr>
         <p:spPr>
           <a:xfrm>
-            <a:off x="713232" y="3547872"/>
-            <a:ext cx="10744200" cy="512064"/>
+            <a:off x="713232" y="3456432"/>
+            <a:ext cx="10744200" cy="493776"/>
           </a:xfrm>
           <a:prstGeom prst="roundRect">
             <a:avLst>
@@ -12697,14 +12841,14 @@
       </p:sp>
       <p:sp>
         <p:nvSpPr>
-          <p:cNvPr id="22" name="Rectangle 21"/>
+          <p:cNvPr id="25" name="Rectangle 24"/>
           <p:cNvSpPr/>
           <p:nvPr/>
         </p:nvSpPr>
         <p:spPr>
           <a:xfrm>
-            <a:off x="713232" y="3547872"/>
-            <a:ext cx="82296" cy="512064"/>
+            <a:off x="713232" y="3456432"/>
+            <a:ext cx="82296" cy="493776"/>
           </a:xfrm>
           <a:prstGeom prst="rect">
             <a:avLst/>
@@ -12741,14 +12885,14 @@
       </p:sp>
       <p:sp>
         <p:nvSpPr>
-          <p:cNvPr id="23" name="TextBox 22"/>
+          <p:cNvPr id="26" name="TextBox 25"/>
           <p:cNvSpPr txBox="1"/>
           <p:nvPr/>
         </p:nvSpPr>
         <p:spPr>
           <a:xfrm>
-            <a:off x="914400" y="3602736"/>
-            <a:ext cx="2834640" cy="420624"/>
+            <a:off x="914400" y="3502152"/>
+            <a:ext cx="2697480" cy="420624"/>
           </a:xfrm>
           <a:prstGeom prst="rect">
             <a:avLst/>
@@ -12774,7 +12918,7 @@
               <a:buNone/>
             </a:pPr>
             <a:r>
-              <a:rPr sz="1250" b="1" i="0" lang="zh-TW">
+              <a:rPr sz="1200" b="1" i="0" lang="zh-TW">
                 <a:solidFill>
                   <a:srgbClr val="162433"/>
                 </a:solidFill>
@@ -12789,14 +12933,14 @@
       </p:sp>
       <p:sp>
         <p:nvSpPr>
-          <p:cNvPr id="24" name="TextBox 23"/>
+          <p:cNvPr id="27" name="TextBox 26"/>
           <p:cNvSpPr txBox="1"/>
           <p:nvPr/>
         </p:nvSpPr>
         <p:spPr>
           <a:xfrm>
-            <a:off x="3794760" y="3602736"/>
-            <a:ext cx="5852160" cy="420624"/>
+            <a:off x="3657600" y="3502152"/>
+            <a:ext cx="4480560" cy="420624"/>
           </a:xfrm>
           <a:prstGeom prst="rect">
             <a:avLst/>
@@ -12822,7 +12966,7 @@
               <a:buNone/>
             </a:pPr>
             <a:r>
-              <a:rPr sz="1100" b="0" i="0" lang="zh-TW">
+              <a:rPr sz="1050" b="0" i="0" lang="zh-TW">
                 <a:solidFill>
                   <a:srgbClr val="33414F"/>
                 </a:solidFill>
@@ -12830,20 +12974,68 @@
                 <a:ea typeface="Microsoft JhengHei"/>
                 <a:cs typeface="Microsoft JhengHei"/>
               </a:rPr>
-              <a:t>紅外線體溫計外掛 · 相機 OCR 讀體溫計顯示</a:t>
-            </a:r>
-          </a:p>
-        </p:txBody>
-      </p:sp>
-      <p:sp>
-        <p:nvSpPr>
-          <p:cNvPr id="25" name="Rounded Rectangle 24"/>
+              <a:t>紅外線體溫計外掛 · 相機 OCR 讀顯示</a:t>
+            </a:r>
+          </a:p>
+        </p:txBody>
+      </p:sp>
+      <p:sp>
+        <p:nvSpPr>
+          <p:cNvPr id="28" name="TextBox 27"/>
+          <p:cNvSpPr txBox="1"/>
+          <p:nvPr/>
+        </p:nvSpPr>
+        <p:spPr>
+          <a:xfrm>
+            <a:off x="8211312" y="3502152"/>
+            <a:ext cx="1783080" cy="420624"/>
+          </a:xfrm>
+          <a:prstGeom prst="rect">
+            <a:avLst/>
+          </a:prstGeom>
+          <a:noFill/>
+        </p:spPr>
+        <p:txBody>
+          <a:bodyPr wrap="square" anchor="ctr" lIns="0" rIns="0" tIns="0" bIns="0">
+            <a:spAutoFit/>
+          </a:bodyPr>
+          <a:lstStyle/>
+          <a:p>
+            <a:pPr algn="l">
+              <a:lnSpc>
+                <a:spcPct val="100000"/>
+              </a:lnSpc>
+              <a:spcBef>
+                <a:spcPts val="0"/>
+              </a:spcBef>
+              <a:spcAft>
+                <a:spcPts val="400"/>
+              </a:spcAft>
+              <a:buNone/>
+            </a:pPr>
+            <a:r>
+              <a:rPr sz="1050" b="1" i="0" lang="zh-TW">
+                <a:solidFill>
+                  <a:srgbClr val="1F9EB3"/>
+                </a:solidFill>
+                <a:latin typeface="Segoe UI"/>
+                <a:ea typeface="Microsoft JhengHei"/>
+                <a:cs typeface="Microsoft JhengHei"/>
+              </a:rPr>
+              <a:t>論文 1·3</a:t>
+            </a:r>
+          </a:p>
+        </p:txBody>
+      </p:sp>
+      <p:sp>
+        <p:nvSpPr>
+          <p:cNvPr id="29" name="Rounded Rectangle 28"/>
           <p:cNvSpPr/>
           <p:nvPr/>
         </p:nvSpPr>
         <p:spPr>
           <a:xfrm>
-            <a:off x="10698099" y="3639312"/>
+            <a:off x="10698099" y="3538728"/>
             <a:ext cx="658749" cy="329184"/>
           </a:xfrm>
           <a:prstGeom prst="roundRect">
@@ -12905,14 +13097,14 @@
       </p:sp>
       <p:sp>
         <p:nvSpPr>
-          <p:cNvPr id="26" name="Rounded Rectangle 25"/>
+          <p:cNvPr id="30" name="Rounded Rectangle 29"/>
           <p:cNvSpPr/>
           <p:nvPr/>
         </p:nvSpPr>
         <p:spPr>
           <a:xfrm>
-            <a:off x="713232" y="4151376"/>
-            <a:ext cx="10744200" cy="512064"/>
+            <a:off x="713232" y="4041648"/>
+            <a:ext cx="10744200" cy="493776"/>
           </a:xfrm>
           <a:prstGeom prst="roundRect">
             <a:avLst>
@@ -12951,14 +13143,14 @@
       </p:sp>
       <p:sp>
         <p:nvSpPr>
-          <p:cNvPr id="27" name="Rectangle 26"/>
+          <p:cNvPr id="31" name="Rectangle 30"/>
           <p:cNvSpPr/>
           <p:nvPr/>
         </p:nvSpPr>
         <p:spPr>
           <a:xfrm>
-            <a:off x="713232" y="4151376"/>
-            <a:ext cx="82296" cy="512064"/>
+            <a:off x="713232" y="4041648"/>
+            <a:ext cx="82296" cy="493776"/>
           </a:xfrm>
           <a:prstGeom prst="rect">
             <a:avLst/>
@@ -12995,14 +13187,14 @@
       </p:sp>
       <p:sp>
         <p:nvSpPr>
-          <p:cNvPr id="28" name="TextBox 27"/>
+          <p:cNvPr id="32" name="TextBox 31"/>
           <p:cNvSpPr txBox="1"/>
           <p:nvPr/>
         </p:nvSpPr>
         <p:spPr>
           <a:xfrm>
-            <a:off x="914400" y="4206240"/>
-            <a:ext cx="2834640" cy="420624"/>
+            <a:off x="914400" y="4087368"/>
+            <a:ext cx="2697480" cy="420624"/>
           </a:xfrm>
           <a:prstGeom prst="rect">
             <a:avLst/>
@@ -13028,7 +13220,7 @@
               <a:buNone/>
             </a:pPr>
             <a:r>
-              <a:rPr sz="1250" b="1" i="0" lang="zh-TW">
+              <a:rPr sz="1200" b="1" i="0" lang="zh-TW">
                 <a:solidFill>
                   <a:srgbClr val="162433"/>
                 </a:solidFill>
@@ -13043,14 +13235,14 @@
       </p:sp>
       <p:sp>
         <p:nvSpPr>
-          <p:cNvPr id="29" name="TextBox 28"/>
+          <p:cNvPr id="33" name="TextBox 32"/>
           <p:cNvSpPr txBox="1"/>
           <p:nvPr/>
         </p:nvSpPr>
         <p:spPr>
           <a:xfrm>
-            <a:off x="3794760" y="4206240"/>
-            <a:ext cx="5852160" cy="420624"/>
+            <a:off x="3657600" y="4087368"/>
+            <a:ext cx="4480560" cy="420624"/>
           </a:xfrm>
           <a:prstGeom prst="rect">
             <a:avLst/>
@@ -13076,7 +13268,7 @@
               <a:buNone/>
             </a:pPr>
             <a:r>
-              <a:rPr sz="1100" b="0" i="0" lang="zh-TW">
+              <a:rPr sz="1050" b="0" i="0" lang="zh-TW">
                 <a:solidFill>
                   <a:srgbClr val="33414F"/>
                 </a:solidFill>
@@ -13084,20 +13276,68 @@
                 <a:ea typeface="Microsoft JhengHei"/>
                 <a:cs typeface="Microsoft JhengHei"/>
               </a:rPr>
-              <a:t>多半仍需壓脈帶；純手機量測尚不可靠</a:t>
-            </a:r>
-          </a:p>
-        </p:txBody>
-      </p:sp>
-      <p:sp>
-        <p:nvSpPr>
-          <p:cNvPr id="30" name="Rounded Rectangle 29"/>
+              <a:t>壓脈帶手動輸入；純手機量測尚不可靠</a:t>
+            </a:r>
+          </a:p>
+        </p:txBody>
+      </p:sp>
+      <p:sp>
+        <p:nvSpPr>
+          <p:cNvPr id="34" name="TextBox 33"/>
+          <p:cNvSpPr txBox="1"/>
+          <p:nvPr/>
+        </p:nvSpPr>
+        <p:spPr>
+          <a:xfrm>
+            <a:off x="8211312" y="4087368"/>
+            <a:ext cx="1783080" cy="420624"/>
+          </a:xfrm>
+          <a:prstGeom prst="rect">
+            <a:avLst/>
+          </a:prstGeom>
+          <a:noFill/>
+        </p:spPr>
+        <p:txBody>
+          <a:bodyPr wrap="square" anchor="ctr" lIns="0" rIns="0" tIns="0" bIns="0">
+            <a:spAutoFit/>
+          </a:bodyPr>
+          <a:lstStyle/>
+          <a:p>
+            <a:pPr algn="l">
+              <a:lnSpc>
+                <a:spcPct val="100000"/>
+              </a:lnSpc>
+              <a:spcBef>
+                <a:spcPts val="0"/>
+              </a:spcBef>
+              <a:spcAft>
+                <a:spcPts val="400"/>
+              </a:spcAft>
+              <a:buNone/>
+            </a:pPr>
+            <a:r>
+              <a:rPr sz="1050" b="1" i="0" lang="zh-TW">
+                <a:solidFill>
+                  <a:srgbClr val="1F9EB3"/>
+                </a:solidFill>
+                <a:latin typeface="Segoe UI"/>
+                <a:ea typeface="Microsoft JhengHei"/>
+                <a:cs typeface="Microsoft JhengHei"/>
+              </a:rPr>
+              <a:t>論文 2</a:t>
+            </a:r>
+          </a:p>
+        </p:txBody>
+      </p:sp>
+      <p:sp>
+        <p:nvSpPr>
+          <p:cNvPr id="35" name="Rounded Rectangle 34"/>
           <p:cNvSpPr/>
           <p:nvPr/>
         </p:nvSpPr>
         <p:spPr>
           <a:xfrm>
-            <a:off x="10698099" y="4242816"/>
+            <a:off x="10698099" y="4123944"/>
             <a:ext cx="658749" cy="329184"/>
           </a:xfrm>
           <a:prstGeom prst="roundRect">
@@ -13159,14 +13399,14 @@
       </p:sp>
       <p:sp>
         <p:nvSpPr>
-          <p:cNvPr id="31" name="Rounded Rectangle 30"/>
+          <p:cNvPr id="36" name="Rounded Rectangle 35"/>
           <p:cNvSpPr/>
           <p:nvPr/>
         </p:nvSpPr>
         <p:spPr>
           <a:xfrm>
-            <a:off x="713232" y="4754880"/>
-            <a:ext cx="10744200" cy="512064"/>
+            <a:off x="713232" y="4626864"/>
+            <a:ext cx="10744200" cy="493776"/>
           </a:xfrm>
           <a:prstGeom prst="roundRect">
             <a:avLst>
@@ -13205,14 +13445,14 @@
       </p:sp>
       <p:sp>
         <p:nvSpPr>
-          <p:cNvPr id="32" name="Rectangle 31"/>
+          <p:cNvPr id="37" name="Rectangle 36"/>
           <p:cNvSpPr/>
           <p:nvPr/>
         </p:nvSpPr>
         <p:spPr>
           <a:xfrm>
-            <a:off x="713232" y="4754880"/>
-            <a:ext cx="82296" cy="512064"/>
+            <a:off x="713232" y="4626864"/>
+            <a:ext cx="82296" cy="493776"/>
           </a:xfrm>
           <a:prstGeom prst="rect">
             <a:avLst/>
@@ -13249,14 +13489,14 @@
       </p:sp>
       <p:sp>
         <p:nvSpPr>
-          <p:cNvPr id="33" name="TextBox 32"/>
+          <p:cNvPr id="38" name="TextBox 37"/>
           <p:cNvSpPr txBox="1"/>
           <p:nvPr/>
         </p:nvSpPr>
         <p:spPr>
           <a:xfrm>
-            <a:off x="914400" y="4809744"/>
-            <a:ext cx="2834640" cy="420624"/>
+            <a:off x="914400" y="4672584"/>
+            <a:ext cx="2697480" cy="420624"/>
           </a:xfrm>
           <a:prstGeom prst="rect">
             <a:avLst/>
@@ -13282,7 +13522,7 @@
               <a:buNone/>
             </a:pPr>
             <a:r>
-              <a:rPr sz="1250" b="1" i="0" lang="zh-TW">
+              <a:rPr sz="1200" b="1" i="0" lang="zh-TW">
                 <a:solidFill>
                   <a:srgbClr val="162433"/>
                 </a:solidFill>
@@ -13297,14 +13537,14 @@
       </p:sp>
       <p:sp>
         <p:nvSpPr>
-          <p:cNvPr id="34" name="TextBox 33"/>
+          <p:cNvPr id="39" name="TextBox 38"/>
           <p:cNvSpPr txBox="1"/>
           <p:nvPr/>
         </p:nvSpPr>
         <p:spPr>
           <a:xfrm>
-            <a:off x="3794760" y="4809744"/>
-            <a:ext cx="5852160" cy="420624"/>
+            <a:off x="3657600" y="4672584"/>
+            <a:ext cx="4480560" cy="420624"/>
           </a:xfrm>
           <a:prstGeom prst="rect">
             <a:avLst/>
@@ -13330,7 +13570,7 @@
               <a:buNone/>
             </a:pPr>
             <a:r>
-              <a:rPr sz="1100" b="0" i="0" lang="zh-TW">
+              <a:rPr sz="1050" b="0" i="0" lang="zh-TW">
                 <a:solidFill>
                   <a:srgbClr val="33414F"/>
                 </a:solidFill>
@@ -13338,20 +13578,68 @@
                 <a:ea typeface="Microsoft JhengHei"/>
                 <a:cs typeface="Microsoft JhengHei"/>
               </a:rPr>
-              <a:t>手機麥克風錄音（自動分類仍在研究）</a:t>
-            </a:r>
-          </a:p>
-        </p:txBody>
-      </p:sp>
-      <p:sp>
-        <p:nvSpPr>
-          <p:cNvPr id="35" name="Rounded Rectangle 34"/>
+              <a:t>手機麥克風錄音（自動分類仍研究）</a:t>
+            </a:r>
+          </a:p>
+        </p:txBody>
+      </p:sp>
+      <p:sp>
+        <p:nvSpPr>
+          <p:cNvPr id="40" name="TextBox 39"/>
+          <p:cNvSpPr txBox="1"/>
+          <p:nvPr/>
+        </p:nvSpPr>
+        <p:spPr>
+          <a:xfrm>
+            <a:off x="8211312" y="4672584"/>
+            <a:ext cx="1783080" cy="420624"/>
+          </a:xfrm>
+          <a:prstGeom prst="rect">
+            <a:avLst/>
+          </a:prstGeom>
+          <a:noFill/>
+        </p:spPr>
+        <p:txBody>
+          <a:bodyPr wrap="square" anchor="ctr" lIns="0" rIns="0" tIns="0" bIns="0">
+            <a:spAutoFit/>
+          </a:bodyPr>
+          <a:lstStyle/>
+          <a:p>
+            <a:pPr algn="l">
+              <a:lnSpc>
+                <a:spcPct val="100000"/>
+              </a:lnSpc>
+              <a:spcBef>
+                <a:spcPts val="0"/>
+              </a:spcBef>
+              <a:spcAft>
+                <a:spcPts val="400"/>
+              </a:spcAft>
+              <a:buNone/>
+            </a:pPr>
+            <a:r>
+              <a:rPr sz="1050" b="1" i="0" lang="zh-TW">
+                <a:solidFill>
+                  <a:srgbClr val="1F9EB3"/>
+                </a:solidFill>
+                <a:latin typeface="Segoe UI"/>
+                <a:ea typeface="Microsoft JhengHei"/>
+                <a:cs typeface="Microsoft JhengHei"/>
+              </a:rPr>
+              <a:t>論文 3</a:t>
+            </a:r>
+          </a:p>
+        </p:txBody>
+      </p:sp>
+      <p:sp>
+        <p:nvSpPr>
+          <p:cNvPr id="41" name="Rounded Rectangle 40"/>
           <p:cNvSpPr/>
           <p:nvPr/>
         </p:nvSpPr>
         <p:spPr>
           <a:xfrm>
-            <a:off x="10560749" y="4846320"/>
+            <a:off x="10560749" y="4709160"/>
             <a:ext cx="796099" cy="329184"/>
           </a:xfrm>
           <a:prstGeom prst="roundRect">
@@ -13413,14 +13701,14 @@
       </p:sp>
       <p:sp>
         <p:nvSpPr>
-          <p:cNvPr id="36" name="Rounded Rectangle 35"/>
+          <p:cNvPr id="42" name="Rounded Rectangle 41"/>
           <p:cNvSpPr/>
           <p:nvPr/>
         </p:nvSpPr>
         <p:spPr>
           <a:xfrm>
-            <a:off x="713232" y="5358384"/>
-            <a:ext cx="10744200" cy="512064"/>
+            <a:off x="713232" y="5212080"/>
+            <a:ext cx="10744200" cy="493776"/>
           </a:xfrm>
           <a:prstGeom prst="roundRect">
             <a:avLst>
@@ -13459,14 +13747,14 @@
       </p:sp>
       <p:sp>
         <p:nvSpPr>
-          <p:cNvPr id="37" name="Rectangle 36"/>
+          <p:cNvPr id="43" name="Rectangle 42"/>
           <p:cNvSpPr/>
           <p:nvPr/>
         </p:nvSpPr>
         <p:spPr>
           <a:xfrm>
-            <a:off x="713232" y="5358384"/>
-            <a:ext cx="82296" cy="512064"/>
+            <a:off x="713232" y="5212080"/>
+            <a:ext cx="82296" cy="493776"/>
           </a:xfrm>
           <a:prstGeom prst="rect">
             <a:avLst/>
@@ -13503,14 +13791,14 @@
       </p:sp>
       <p:sp>
         <p:nvSpPr>
-          <p:cNvPr id="38" name="TextBox 37"/>
+          <p:cNvPr id="44" name="TextBox 43"/>
           <p:cNvSpPr txBox="1"/>
           <p:nvPr/>
         </p:nvSpPr>
         <p:spPr>
           <a:xfrm>
-            <a:off x="914400" y="5413248"/>
-            <a:ext cx="2834640" cy="420624"/>
+            <a:off x="914400" y="5257800"/>
+            <a:ext cx="2697480" cy="420624"/>
           </a:xfrm>
           <a:prstGeom prst="rect">
             <a:avLst/>
@@ -13536,7 +13824,7 @@
               <a:buNone/>
             </a:pPr>
             <a:r>
-              <a:rPr sz="1250" b="1" i="0" lang="zh-TW">
+              <a:rPr sz="1200" b="1" i="0" lang="zh-TW">
                 <a:solidFill>
                   <a:srgbClr val="162433"/>
                 </a:solidFill>
@@ -13551,14 +13839,14 @@
       </p:sp>
       <p:sp>
         <p:nvSpPr>
-          <p:cNvPr id="39" name="TextBox 38"/>
+          <p:cNvPr id="45" name="TextBox 44"/>
           <p:cNvSpPr txBox="1"/>
           <p:nvPr/>
         </p:nvSpPr>
         <p:spPr>
           <a:xfrm>
-            <a:off x="3794760" y="5413248"/>
-            <a:ext cx="5852160" cy="420624"/>
+            <a:off x="3657600" y="5257800"/>
+            <a:ext cx="4480560" cy="420624"/>
           </a:xfrm>
           <a:prstGeom prst="rect">
             <a:avLst/>
@@ -13584,7 +13872,7 @@
               <a:buNone/>
             </a:pPr>
             <a:r>
-              <a:rPr sz="1100" b="0" i="0" lang="zh-TW">
+              <a:rPr sz="1050" b="0" i="0" lang="zh-TW">
                 <a:solidFill>
                   <a:srgbClr val="33414F"/>
                 </a:solidFill>
@@ -13599,13 +13887,61 @@
       </p:sp>
       <p:sp>
         <p:nvSpPr>
-          <p:cNvPr id="40" name="Rounded Rectangle 39"/>
+          <p:cNvPr id="46" name="TextBox 45"/>
+          <p:cNvSpPr txBox="1"/>
+          <p:nvPr/>
+        </p:nvSpPr>
+        <p:spPr>
+          <a:xfrm>
+            <a:off x="8211312" y="5257800"/>
+            <a:ext cx="1783080" cy="420624"/>
+          </a:xfrm>
+          <a:prstGeom prst="rect">
+            <a:avLst/>
+          </a:prstGeom>
+          <a:noFill/>
+        </p:spPr>
+        <p:txBody>
+          <a:bodyPr wrap="square" anchor="ctr" lIns="0" rIns="0" tIns="0" bIns="0">
+            <a:spAutoFit/>
+          </a:bodyPr>
+          <a:lstStyle/>
+          <a:p>
+            <a:pPr algn="l">
+              <a:lnSpc>
+                <a:spcPct val="100000"/>
+              </a:lnSpc>
+              <a:spcBef>
+                <a:spcPts val="0"/>
+              </a:spcBef>
+              <a:spcAft>
+                <a:spcPts val="400"/>
+              </a:spcAft>
+              <a:buNone/>
+            </a:pPr>
+            <a:r>
+              <a:rPr sz="1050" b="1" i="0" lang="zh-TW">
+                <a:solidFill>
+                  <a:srgbClr val="1F9EB3"/>
+                </a:solidFill>
+                <a:latin typeface="Segoe UI"/>
+                <a:ea typeface="Microsoft JhengHei"/>
+                <a:cs typeface="Microsoft JhengHei"/>
+              </a:rPr>
+              <a:t>論文 1·2</a:t>
+            </a:r>
+          </a:p>
+        </p:txBody>
+      </p:sp>
+      <p:sp>
+        <p:nvSpPr>
+          <p:cNvPr id="47" name="Rounded Rectangle 46"/>
           <p:cNvSpPr/>
           <p:nvPr/>
         </p:nvSpPr>
         <p:spPr>
           <a:xfrm>
-            <a:off x="10423398" y="5449824"/>
+            <a:off x="10423398" y="5294376"/>
             <a:ext cx="933450" cy="329184"/>
           </a:xfrm>
           <a:prstGeom prst="roundRect">
@@ -13667,14 +14003,14 @@
       </p:sp>
       <p:sp>
         <p:nvSpPr>
-          <p:cNvPr id="41" name="Rounded Rectangle 40"/>
+          <p:cNvPr id="48" name="Rounded Rectangle 47"/>
           <p:cNvSpPr/>
           <p:nvPr/>
         </p:nvSpPr>
         <p:spPr>
           <a:xfrm>
-            <a:off x="713232" y="5943600"/>
-            <a:ext cx="10744200" cy="420624"/>
+            <a:off x="713232" y="5870448"/>
+            <a:ext cx="10744200" cy="548640"/>
           </a:xfrm>
           <a:prstGeom prst="roundRect">
             <a:avLst>
@@ -13713,14 +14049,14 @@
       </p:sp>
       <p:sp>
         <p:nvSpPr>
-          <p:cNvPr id="42" name="Rectangle 41"/>
+          <p:cNvPr id="49" name="Rectangle 48"/>
           <p:cNvSpPr/>
           <p:nvPr/>
         </p:nvSpPr>
         <p:spPr>
           <a:xfrm>
-            <a:off x="713232" y="5943600"/>
-            <a:ext cx="91440" cy="420624"/>
+            <a:off x="713232" y="5870448"/>
+            <a:ext cx="91440" cy="548640"/>
           </a:xfrm>
           <a:prstGeom prst="rect">
             <a:avLst/>
@@ -13757,14 +14093,14 @@
       </p:sp>
       <p:sp>
         <p:nvSpPr>
-          <p:cNvPr id="43" name="TextBox 42"/>
+          <p:cNvPr id="50" name="TextBox 49"/>
           <p:cNvSpPr txBox="1"/>
           <p:nvPr/>
         </p:nvSpPr>
         <p:spPr>
           <a:xfrm>
-            <a:off x="950976" y="6071616"/>
-            <a:ext cx="10360152" cy="201168"/>
+            <a:off x="950976" y="5998464"/>
+            <a:ext cx="10360152" cy="329184"/>
           </a:xfrm>
           <a:prstGeom prst="rect">
             <a:avLst/>
@@ -13798,7 +14134,7 @@
                 <a:ea typeface="Microsoft JhengHei"/>
                 <a:cs typeface="Microsoft JhengHei"/>
               </a:rPr>
-              <a:t>小結：真正便宜（&lt;NT$5000）能穩定取得的以心率、血氧、體溫、呼吸為主；血壓與聲音類仍是弱點。</a:t>
+              <a:t>註：論文 4（Joseph）不新增感測，直接沿用 EHR 既有生命徵象數字；上表列的是「用便宜設備主動取得」的對應。真正穩定 &lt;NT$5000 的以心率、血氧、體溫、呼吸為主，血壓與聲音類仍是弱點。</a:t>
             </a:r>
           </a:p>
         </p:txBody>
@@ -14165,7 +14501,7 @@
                 <a:ea typeface="Microsoft JhengHei"/>
                 <a:cs typeface="Microsoft JhengHei"/>
               </a:rPr>
-              <a:t>例：Smart Triage、miniPIERS（logistic 回歸）</a:t>
+              <a:t>→ 論文 1 Smart Triage、論文 2 PIERS（logistic 回歸）</a:t>
             </a:r>
           </a:p>
           <a:p>
@@ -14378,7 +14714,7 @@
                 <a:ea typeface="Microsoft JhengHei"/>
                 <a:cs typeface="Microsoft JhengHei"/>
               </a:rPr>
-              <a:t>例：Joseph 2020（加主訴 AUC 0.82→0.85）</a:t>
+              <a:t>→ 論文 4 Joseph（加主訴 AUC 0.82→0.85）</a:t>
             </a:r>
           </a:p>
           <a:p>
@@ -14591,7 +14927,7 @@
                 <a:ea typeface="Microsoft JhengHei"/>
                 <a:cs typeface="Microsoft JhengHei"/>
               </a:rPr>
-              <a:t>例：e-CoVig</a:t>
+              <a:t>→ 論文 3 e-CoVig</a:t>
             </a:r>
           </a:p>
           <a:p>
@@ -14804,7 +15140,7 @@
                 <a:ea typeface="Microsoft JhengHei"/>
                 <a:cs typeface="Microsoft JhengHei"/>
               </a:rPr>
-              <a:t>常作為比較基準</a:t>
+              <a:t>→ 論文 4 用 ESI 當對照；論文 1 勾選項源自 WHO 危險徵象</a:t>
             </a:r>
           </a:p>
           <a:p>

</xml_diff>

<commit_message>
Upgrade AI-paper verification via GitHub source code (author repos)
Fetched companion code on GitHub (the only reachable host) to upgrade several
'search-evidenced' papers to '已見原文' (primary source seen):
- Hannun 2019 ECG -> github.com/awni/ecg (official, 34-layer residual CNN)
- Hsu 2020 cuffless BP -> github.com/Yan-Cheng-Hsu/... (official, DNN)
- Ming 2024 dengue wearable -> github.com/jsmdaniels/VITAL (official, transformer)
- Pahar 2021 cough -> github.com/raina-akshay/covidfromcough (third-party CNN)
Each AI-paper slide now footnotes the exact GitHub repos. Anemia/jaundice/pupil/
CGM/gait stay 搜尋佐證 (no fetchable code); CRT stays 無; respiratory-audio weak.

Co-Authored-By: Claude Opus 4.8 <noreply@anthropic.com>
Claude-Session: https://claude.ai/code/session_01CFRiU1zo6fRgreoXqaJ1e6
</commit_message>
<xml_diff>
--- a/ppt/低成本設備輔助檢傷_報告版.pptx
+++ b/ppt/低成本設備輔助檢傷_報告版.pptx
@@ -28814,7 +28814,7 @@
         </p:nvSpPr>
         <p:spPr>
           <a:xfrm>
-            <a:off x="713232" y="1188720"/>
+            <a:off x="713232" y="1170432"/>
             <a:ext cx="10744200" cy="457200"/>
           </a:xfrm>
           <a:prstGeom prst="rect">
@@ -28862,8 +28862,8 @@
         </p:nvSpPr>
         <p:spPr>
           <a:xfrm>
-            <a:off x="713232" y="1773936"/>
-            <a:ext cx="10744200" cy="493776"/>
+            <a:off x="713232" y="1700784"/>
+            <a:ext cx="10744200" cy="457200"/>
           </a:xfrm>
           <a:prstGeom prst="roundRect">
             <a:avLst>
@@ -28908,8 +28908,8 @@
         </p:nvSpPr>
         <p:spPr>
           <a:xfrm>
-            <a:off x="713232" y="1773936"/>
-            <a:ext cx="82296" cy="493776"/>
+            <a:off x="713232" y="1700784"/>
+            <a:ext cx="82296" cy="457200"/>
           </a:xfrm>
           <a:prstGeom prst="rect">
             <a:avLst/>
@@ -28952,8 +28952,8 @@
         </p:nvSpPr>
         <p:spPr>
           <a:xfrm>
-            <a:off x="914400" y="1819656"/>
-            <a:ext cx="2743200" cy="420624"/>
+            <a:off x="914400" y="1737360"/>
+            <a:ext cx="2743200" cy="402336"/>
           </a:xfrm>
           <a:prstGeom prst="rect">
             <a:avLst/>
@@ -29025,8 +29025,8 @@
         </p:nvSpPr>
         <p:spPr>
           <a:xfrm>
-            <a:off x="3749039" y="1819656"/>
-            <a:ext cx="5394960" cy="420624"/>
+            <a:off x="3749039" y="1737360"/>
+            <a:ext cx="5394960" cy="402336"/>
           </a:xfrm>
           <a:prstGeom prst="rect">
             <a:avLst/>
@@ -29073,7 +29073,7 @@
         </p:nvSpPr>
         <p:spPr>
           <a:xfrm>
-            <a:off x="10504424" y="1856232"/>
+            <a:off x="10504424" y="1773936"/>
             <a:ext cx="852424" cy="310896"/>
           </a:xfrm>
           <a:prstGeom prst="roundRect">
@@ -29141,8 +29141,8 @@
         </p:nvSpPr>
         <p:spPr>
           <a:xfrm>
-            <a:off x="713232" y="2340864"/>
-            <a:ext cx="10744200" cy="493776"/>
+            <a:off x="713232" y="2235708"/>
+            <a:ext cx="10744200" cy="457200"/>
           </a:xfrm>
           <a:prstGeom prst="roundRect">
             <a:avLst>
@@ -29187,8 +29187,8 @@
         </p:nvSpPr>
         <p:spPr>
           <a:xfrm>
-            <a:off x="713232" y="2340864"/>
-            <a:ext cx="82296" cy="493776"/>
+            <a:off x="713232" y="2235708"/>
+            <a:ext cx="82296" cy="457200"/>
           </a:xfrm>
           <a:prstGeom prst="rect">
             <a:avLst/>
@@ -29231,8 +29231,8 @@
         </p:nvSpPr>
         <p:spPr>
           <a:xfrm>
-            <a:off x="914400" y="2386584"/>
-            <a:ext cx="2743200" cy="420624"/>
+            <a:off x="914400" y="2272284"/>
+            <a:ext cx="2743200" cy="402336"/>
           </a:xfrm>
           <a:prstGeom prst="rect">
             <a:avLst/>
@@ -29304,8 +29304,8 @@
         </p:nvSpPr>
         <p:spPr>
           <a:xfrm>
-            <a:off x="3749039" y="2386584"/>
-            <a:ext cx="5394960" cy="420624"/>
+            <a:off x="3749039" y="2272284"/>
+            <a:ext cx="5394960" cy="402336"/>
           </a:xfrm>
           <a:prstGeom prst="rect">
             <a:avLst/>
@@ -29352,7 +29352,7 @@
         </p:nvSpPr>
         <p:spPr>
           <a:xfrm>
-            <a:off x="10504424" y="2423160"/>
+            <a:off x="10504424" y="2308860"/>
             <a:ext cx="852424" cy="310896"/>
           </a:xfrm>
           <a:prstGeom prst="roundRect">
@@ -29420,8 +29420,8 @@
         </p:nvSpPr>
         <p:spPr>
           <a:xfrm>
-            <a:off x="713232" y="2907792"/>
-            <a:ext cx="10744200" cy="493776"/>
+            <a:off x="713232" y="2770632"/>
+            <a:ext cx="10744200" cy="457200"/>
           </a:xfrm>
           <a:prstGeom prst="roundRect">
             <a:avLst>
@@ -29466,8 +29466,8 @@
         </p:nvSpPr>
         <p:spPr>
           <a:xfrm>
-            <a:off x="713232" y="2907792"/>
-            <a:ext cx="82296" cy="493776"/>
+            <a:off x="713232" y="2770632"/>
+            <a:ext cx="82296" cy="457200"/>
           </a:xfrm>
           <a:prstGeom prst="rect">
             <a:avLst/>
@@ -29510,8 +29510,8 @@
         </p:nvSpPr>
         <p:spPr>
           <a:xfrm>
-            <a:off x="914400" y="2953512"/>
-            <a:ext cx="2743200" cy="420624"/>
+            <a:off x="914400" y="2807208"/>
+            <a:ext cx="2743200" cy="402336"/>
           </a:xfrm>
           <a:prstGeom prst="rect">
             <a:avLst/>
@@ -29583,8 +29583,8 @@
         </p:nvSpPr>
         <p:spPr>
           <a:xfrm>
-            <a:off x="3749039" y="2953512"/>
-            <a:ext cx="5394960" cy="420624"/>
+            <a:off x="3749039" y="2807208"/>
+            <a:ext cx="5394960" cy="402336"/>
           </a:xfrm>
           <a:prstGeom prst="rect">
             <a:avLst/>
@@ -29631,7 +29631,7 @@
         </p:nvSpPr>
         <p:spPr>
           <a:xfrm>
-            <a:off x="10504424" y="2990088"/>
+            <a:off x="10504424" y="2843784"/>
             <a:ext cx="852424" cy="310896"/>
           </a:xfrm>
           <a:prstGeom prst="roundRect">
@@ -29699,8 +29699,8 @@
         </p:nvSpPr>
         <p:spPr>
           <a:xfrm>
-            <a:off x="713232" y="3474720"/>
-            <a:ext cx="10744200" cy="493776"/>
+            <a:off x="713232" y="3305556"/>
+            <a:ext cx="10744200" cy="457200"/>
           </a:xfrm>
           <a:prstGeom prst="roundRect">
             <a:avLst>
@@ -29745,8 +29745,8 @@
         </p:nvSpPr>
         <p:spPr>
           <a:xfrm>
-            <a:off x="713232" y="3474720"/>
-            <a:ext cx="82296" cy="493776"/>
+            <a:off x="713232" y="3305556"/>
+            <a:ext cx="82296" cy="457200"/>
           </a:xfrm>
           <a:prstGeom prst="rect">
             <a:avLst/>
@@ -29789,8 +29789,8 @@
         </p:nvSpPr>
         <p:spPr>
           <a:xfrm>
-            <a:off x="914400" y="3520440"/>
-            <a:ext cx="2743200" cy="420624"/>
+            <a:off x="914400" y="3342132"/>
+            <a:ext cx="2743200" cy="402336"/>
           </a:xfrm>
           <a:prstGeom prst="rect">
             <a:avLst/>
@@ -29862,8 +29862,8 @@
         </p:nvSpPr>
         <p:spPr>
           <a:xfrm>
-            <a:off x="3749039" y="3520440"/>
-            <a:ext cx="5394960" cy="420624"/>
+            <a:off x="3749039" y="3342132"/>
+            <a:ext cx="5394960" cy="402336"/>
           </a:xfrm>
           <a:prstGeom prst="rect">
             <a:avLst/>
@@ -29910,7 +29910,7 @@
         </p:nvSpPr>
         <p:spPr>
           <a:xfrm>
-            <a:off x="10457434" y="3557016"/>
+            <a:off x="10457434" y="3378708"/>
             <a:ext cx="899414" cy="310896"/>
           </a:xfrm>
           <a:prstGeom prst="roundRect">
@@ -29978,8 +29978,8 @@
         </p:nvSpPr>
         <p:spPr>
           <a:xfrm>
-            <a:off x="713232" y="4041648"/>
-            <a:ext cx="10744200" cy="493776"/>
+            <a:off x="713232" y="3840480"/>
+            <a:ext cx="10744200" cy="457200"/>
           </a:xfrm>
           <a:prstGeom prst="roundRect">
             <a:avLst>
@@ -30024,8 +30024,8 @@
         </p:nvSpPr>
         <p:spPr>
           <a:xfrm>
-            <a:off x="713232" y="4041648"/>
-            <a:ext cx="82296" cy="493776"/>
+            <a:off x="713232" y="3840480"/>
+            <a:ext cx="82296" cy="457200"/>
           </a:xfrm>
           <a:prstGeom prst="rect">
             <a:avLst/>
@@ -30068,8 +30068,8 @@
         </p:nvSpPr>
         <p:spPr>
           <a:xfrm>
-            <a:off x="914400" y="4087368"/>
-            <a:ext cx="2743200" cy="420624"/>
+            <a:off x="914400" y="3877056"/>
+            <a:ext cx="2743200" cy="402336"/>
           </a:xfrm>
           <a:prstGeom prst="rect">
             <a:avLst/>
@@ -30141,8 +30141,8 @@
         </p:nvSpPr>
         <p:spPr>
           <a:xfrm>
-            <a:off x="3749039" y="4087368"/>
-            <a:ext cx="5394960" cy="420624"/>
+            <a:off x="3749039" y="3877056"/>
+            <a:ext cx="5394960" cy="402336"/>
           </a:xfrm>
           <a:prstGeom prst="rect">
             <a:avLst/>
@@ -30189,7 +30189,7 @@
         </p:nvSpPr>
         <p:spPr>
           <a:xfrm>
-            <a:off x="10504424" y="4123944"/>
+            <a:off x="10504424" y="3913632"/>
             <a:ext cx="852424" cy="310896"/>
           </a:xfrm>
           <a:prstGeom prst="roundRect">
@@ -30257,8 +30257,8 @@
         </p:nvSpPr>
         <p:spPr>
           <a:xfrm>
-            <a:off x="713232" y="4608576"/>
-            <a:ext cx="10744200" cy="493776"/>
+            <a:off x="713232" y="4375404"/>
+            <a:ext cx="10744200" cy="457200"/>
           </a:xfrm>
           <a:prstGeom prst="roundRect">
             <a:avLst>
@@ -30303,8 +30303,8 @@
         </p:nvSpPr>
         <p:spPr>
           <a:xfrm>
-            <a:off x="713232" y="4608576"/>
-            <a:ext cx="82296" cy="493776"/>
+            <a:off x="713232" y="4375404"/>
+            <a:ext cx="82296" cy="457200"/>
           </a:xfrm>
           <a:prstGeom prst="rect">
             <a:avLst/>
@@ -30347,8 +30347,8 @@
         </p:nvSpPr>
         <p:spPr>
           <a:xfrm>
-            <a:off x="914400" y="4654296"/>
-            <a:ext cx="2743200" cy="420624"/>
+            <a:off x="914400" y="4411980"/>
+            <a:ext cx="2743200" cy="402336"/>
           </a:xfrm>
           <a:prstGeom prst="rect">
             <a:avLst/>
@@ -30420,8 +30420,8 @@
         </p:nvSpPr>
         <p:spPr>
           <a:xfrm>
-            <a:off x="3749039" y="4654296"/>
-            <a:ext cx="5394960" cy="420624"/>
+            <a:off x="3749039" y="4411980"/>
+            <a:ext cx="5394960" cy="402336"/>
           </a:xfrm>
           <a:prstGeom prst="rect">
             <a:avLst/>
@@ -30468,7 +30468,7 @@
         </p:nvSpPr>
         <p:spPr>
           <a:xfrm>
-            <a:off x="10504424" y="4690872"/>
+            <a:off x="10504424" y="4448556"/>
             <a:ext cx="852424" cy="310896"/>
           </a:xfrm>
           <a:prstGeom prst="roundRect">
@@ -30536,8 +30536,8 @@
         </p:nvSpPr>
         <p:spPr>
           <a:xfrm>
-            <a:off x="713232" y="5175504"/>
-            <a:ext cx="10744200" cy="493776"/>
+            <a:off x="713232" y="4910328"/>
+            <a:ext cx="10744200" cy="457200"/>
           </a:xfrm>
           <a:prstGeom prst="roundRect">
             <a:avLst>
@@ -30582,8 +30582,8 @@
         </p:nvSpPr>
         <p:spPr>
           <a:xfrm>
-            <a:off x="713232" y="5175504"/>
-            <a:ext cx="82296" cy="493776"/>
+            <a:off x="713232" y="4910328"/>
+            <a:ext cx="82296" cy="457200"/>
           </a:xfrm>
           <a:prstGeom prst="rect">
             <a:avLst/>
@@ -30626,8 +30626,8 @@
         </p:nvSpPr>
         <p:spPr>
           <a:xfrm>
-            <a:off x="914400" y="5221224"/>
-            <a:ext cx="2743200" cy="420624"/>
+            <a:off x="914400" y="4946904"/>
+            <a:ext cx="2743200" cy="402336"/>
           </a:xfrm>
           <a:prstGeom prst="rect">
             <a:avLst/>
@@ -30699,8 +30699,8 @@
         </p:nvSpPr>
         <p:spPr>
           <a:xfrm>
-            <a:off x="3749039" y="5221224"/>
-            <a:ext cx="5394960" cy="420624"/>
+            <a:off x="3749039" y="4946904"/>
+            <a:ext cx="5394960" cy="402336"/>
           </a:xfrm>
           <a:prstGeom prst="rect">
             <a:avLst/>
@@ -30747,7 +30747,7 @@
         </p:nvSpPr>
         <p:spPr>
           <a:xfrm>
-            <a:off x="10504424" y="5257800"/>
+            <a:off x="10504424" y="4983480"/>
             <a:ext cx="852424" cy="310896"/>
           </a:xfrm>
           <a:prstGeom prst="roundRect">
@@ -30815,8 +30815,8 @@
         </p:nvSpPr>
         <p:spPr>
           <a:xfrm>
-            <a:off x="713232" y="5742432"/>
-            <a:ext cx="10744200" cy="493776"/>
+            <a:off x="713232" y="5445252"/>
+            <a:ext cx="10744200" cy="457200"/>
           </a:xfrm>
           <a:prstGeom prst="roundRect">
             <a:avLst>
@@ -30861,8 +30861,8 @@
         </p:nvSpPr>
         <p:spPr>
           <a:xfrm>
-            <a:off x="713232" y="5742432"/>
-            <a:ext cx="82296" cy="493776"/>
+            <a:off x="713232" y="5445252"/>
+            <a:ext cx="82296" cy="457200"/>
           </a:xfrm>
           <a:prstGeom prst="rect">
             <a:avLst/>
@@ -30905,8 +30905,8 @@
         </p:nvSpPr>
         <p:spPr>
           <a:xfrm>
-            <a:off x="914400" y="5788152"/>
-            <a:ext cx="2743200" cy="420624"/>
+            <a:off x="914400" y="5481828"/>
+            <a:ext cx="2743200" cy="402336"/>
           </a:xfrm>
           <a:prstGeom prst="rect">
             <a:avLst/>
@@ -30978,8 +30978,8 @@
         </p:nvSpPr>
         <p:spPr>
           <a:xfrm>
-            <a:off x="3749039" y="5788152"/>
-            <a:ext cx="5394960" cy="420624"/>
+            <a:off x="3749039" y="5481828"/>
+            <a:ext cx="5394960" cy="402336"/>
           </a:xfrm>
           <a:prstGeom prst="rect">
             <a:avLst/>
@@ -31026,7 +31026,7 @@
         </p:nvSpPr>
         <p:spPr>
           <a:xfrm>
-            <a:off x="10896854" y="5824728"/>
+            <a:off x="10896854" y="5518404"/>
             <a:ext cx="459994" cy="310896"/>
           </a:xfrm>
           <a:prstGeom prst="roundRect">
@@ -31088,14 +31088,104 @@
       </p:sp>
       <p:sp>
         <p:nvSpPr>
-          <p:cNvPr id="46" name="TextBox 45"/>
+          <p:cNvPr id="46" name="Rounded Rectangle 45"/>
+          <p:cNvSpPr/>
+          <p:nvPr/>
+        </p:nvSpPr>
+        <p:spPr>
+          <a:xfrm>
+            <a:off x="713232" y="5943600"/>
+            <a:ext cx="10744200" cy="731520"/>
+          </a:xfrm>
+          <a:prstGeom prst="roundRect">
+            <a:avLst>
+              <a:gd name="adj" fmla="val 6000"/>
+            </a:avLst>
+          </a:prstGeom>
+          <a:solidFill>
+            <a:srgbClr val="ECF6F0"/>
+          </a:solidFill>
+          <a:ln>
+            <a:noFill/>
+          </a:ln>
+          <a:effectLst/>
+        </p:spPr>
+        <p:style>
+          <a:lnRef idx="1">
+            <a:schemeClr val="accent1"/>
+          </a:lnRef>
+          <a:fillRef idx="3">
+            <a:schemeClr val="accent1"/>
+          </a:fillRef>
+          <a:effectRef idx="2">
+            <a:schemeClr val="accent1"/>
+          </a:effectRef>
+          <a:fontRef idx="minor">
+            <a:schemeClr val="lt1"/>
+          </a:fontRef>
+        </p:style>
+        <p:txBody>
+          <a:bodyPr rtlCol="0" anchor="ctr"/>
+          <a:lstStyle/>
+          <a:p>
+            <a:pPr algn="ctr"/>
+          </a:p>
+        </p:txBody>
+      </p:sp>
+      <p:sp>
+        <p:nvSpPr>
+          <p:cNvPr id="47" name="Rectangle 46"/>
+          <p:cNvSpPr/>
+          <p:nvPr/>
+        </p:nvSpPr>
+        <p:spPr>
+          <a:xfrm>
+            <a:off x="713232" y="5943600"/>
+            <a:ext cx="91440" cy="731520"/>
+          </a:xfrm>
+          <a:prstGeom prst="rect">
+            <a:avLst/>
+          </a:prstGeom>
+          <a:solidFill>
+            <a:srgbClr val="2F9E6A"/>
+          </a:solidFill>
+          <a:ln>
+            <a:noFill/>
+          </a:ln>
+          <a:effectLst/>
+        </p:spPr>
+        <p:style>
+          <a:lnRef idx="1">
+            <a:schemeClr val="accent1"/>
+          </a:lnRef>
+          <a:fillRef idx="3">
+            <a:schemeClr val="accent1"/>
+          </a:fillRef>
+          <a:effectRef idx="2">
+            <a:schemeClr val="accent1"/>
+          </a:effectRef>
+          <a:fontRef idx="minor">
+            <a:schemeClr val="lt1"/>
+          </a:fontRef>
+        </p:style>
+        <p:txBody>
+          <a:bodyPr rtlCol="0" anchor="ctr"/>
+          <a:lstStyle/>
+          <a:p>
+            <a:pPr algn="ctr"/>
+          </a:p>
+        </p:txBody>
+      </p:sp>
+      <p:sp>
+        <p:nvSpPr>
+          <p:cNvPr id="48" name="TextBox 47"/>
           <p:cNvSpPr txBox="1"/>
           <p:nvPr/>
         </p:nvSpPr>
         <p:spPr>
           <a:xfrm>
-            <a:off x="502920" y="6419088"/>
-            <a:ext cx="8686800" cy="274320"/>
+            <a:off x="950976" y="6071616"/>
+            <a:ext cx="10360152" cy="512064"/>
           </a:xfrm>
           <a:prstGeom prst="rect">
             <a:avLst/>
@@ -31121,15 +31211,40 @@
               <a:buNone/>
             </a:pPr>
             <a:r>
-              <a:rPr sz="850" b="0" i="0" lang="zh-TW">
-                <a:solidFill>
-                  <a:srgbClr val="6B7885"/>
-                </a:solidFill>
-                <a:latin typeface="Segoe UI"/>
-                <a:ea typeface="Microsoft JhengHei"/>
-                <a:cs typeface="Microsoft JhengHei"/>
-              </a:rPr>
-              <a:t>低成本設備 × 生命徵象 × 主訴 → 初步檢傷 / 急症判斷</a:t>
+              <a:rPr sz="1150" b="1" i="0" lang="zh-TW">
+                <a:solidFill>
+                  <a:srgbClr val="2F9E6A"/>
+                </a:solidFill>
+                <a:latin typeface="Segoe UI"/>
+                <a:ea typeface="Microsoft JhengHei"/>
+                <a:cs typeface="Microsoft JhengHei"/>
+              </a:rPr>
+              <a:t>已見原文的程式碼來源（GitHub 可存取）</a:t>
+            </a:r>
+          </a:p>
+          <a:p>
+            <a:pPr algn="l">
+              <a:lnSpc>
+                <a:spcPct val="116000"/>
+              </a:lnSpc>
+              <a:spcBef>
+                <a:spcPts val="0"/>
+              </a:spcBef>
+              <a:spcAft>
+                <a:spcPts val="400"/>
+              </a:spcAft>
+              <a:buNone/>
+            </a:pPr>
+            <a:r>
+              <a:rPr sz="1150" b="0" i="0" lang="zh-TW">
+                <a:solidFill>
+                  <a:srgbClr val="33414F"/>
+                </a:solidFill>
+                <a:latin typeface="Segoe UI"/>
+                <a:ea typeface="Microsoft JhengHei"/>
+                <a:cs typeface="Microsoft JhengHei"/>
+              </a:rPr>
+              <a:t>MEDVSE：github.com/MahdiFarvardin/MEDVSE　·　Hoffman：github.com/ubicomplab/oximetry-phone-cam-data　·　DeepPhys：github.com/ubicomplab/rPPG-Toolbox</a:t>
             </a:r>
           </a:p>
         </p:txBody>
@@ -31321,7 +31436,7 @@
         </p:nvSpPr>
         <p:spPr>
           <a:xfrm>
-            <a:off x="713232" y="1188720"/>
+            <a:off x="713232" y="1170432"/>
             <a:ext cx="10744200" cy="457200"/>
           </a:xfrm>
           <a:prstGeom prst="rect">
@@ -31369,8 +31484,8 @@
         </p:nvSpPr>
         <p:spPr>
           <a:xfrm>
-            <a:off x="713232" y="1773936"/>
-            <a:ext cx="10744200" cy="493776"/>
+            <a:off x="713232" y="1700784"/>
+            <a:ext cx="10744200" cy="457200"/>
           </a:xfrm>
           <a:prstGeom prst="roundRect">
             <a:avLst>
@@ -31415,14 +31530,14 @@
         </p:nvSpPr>
         <p:spPr>
           <a:xfrm>
-            <a:off x="713232" y="1773936"/>
-            <a:ext cx="82296" cy="493776"/>
-          </a:xfrm>
-          <a:prstGeom prst="rect">
-            <a:avLst/>
-          </a:prstGeom>
-          <a:solidFill>
-            <a:srgbClr val="D99A2B"/>
+            <a:off x="713232" y="1700784"/>
+            <a:ext cx="82296" cy="457200"/>
+          </a:xfrm>
+          <a:prstGeom prst="rect">
+            <a:avLst/>
+          </a:prstGeom>
+          <a:solidFill>
+            <a:srgbClr val="2F9E6A"/>
           </a:solidFill>
           <a:ln>
             <a:noFill/>
@@ -31459,8 +31574,8 @@
         </p:nvSpPr>
         <p:spPr>
           <a:xfrm>
-            <a:off x="914400" y="1819656"/>
-            <a:ext cx="2743200" cy="420624"/>
+            <a:off x="914400" y="1737360"/>
+            <a:ext cx="2743200" cy="402336"/>
           </a:xfrm>
           <a:prstGeom prst="rect">
             <a:avLst/>
@@ -31532,8 +31647,8 @@
         </p:nvSpPr>
         <p:spPr>
           <a:xfrm>
-            <a:off x="3749039" y="1819656"/>
-            <a:ext cx="5394960" cy="420624"/>
+            <a:off x="3749039" y="1737360"/>
+            <a:ext cx="5394960" cy="402336"/>
           </a:xfrm>
           <a:prstGeom prst="rect">
             <a:avLst/>
@@ -31580,7 +31695,7 @@
         </p:nvSpPr>
         <p:spPr>
           <a:xfrm>
-            <a:off x="10504424" y="1856232"/>
+            <a:off x="10504424" y="1773936"/>
             <a:ext cx="852424" cy="310896"/>
           </a:xfrm>
           <a:prstGeom prst="roundRect">
@@ -31589,7 +31704,7 @@
             </a:avLst>
           </a:prstGeom>
           <a:solidFill>
-            <a:srgbClr val="D99A2B"/>
+            <a:srgbClr val="2F9E6A"/>
           </a:solidFill>
           <a:ln>
             <a:noFill/>
@@ -31635,7 +31750,7 @@
                 <a:ea typeface="Microsoft JhengHei"/>
                 <a:cs typeface="Microsoft JhengHei"/>
               </a:rPr>
-              <a:t>搜尋佐證</a:t>
+              <a:t>已見原文</a:t>
             </a:r>
           </a:p>
         </p:txBody>
@@ -31648,8 +31763,8 @@
         </p:nvSpPr>
         <p:spPr>
           <a:xfrm>
-            <a:off x="713232" y="2340864"/>
-            <a:ext cx="10744200" cy="493776"/>
+            <a:off x="713232" y="2235708"/>
+            <a:ext cx="10744200" cy="457200"/>
           </a:xfrm>
           <a:prstGeom prst="roundRect">
             <a:avLst>
@@ -31694,8 +31809,8 @@
         </p:nvSpPr>
         <p:spPr>
           <a:xfrm>
-            <a:off x="713232" y="2340864"/>
-            <a:ext cx="82296" cy="493776"/>
+            <a:off x="713232" y="2235708"/>
+            <a:ext cx="82296" cy="457200"/>
           </a:xfrm>
           <a:prstGeom prst="rect">
             <a:avLst/>
@@ -31738,8 +31853,8 @@
         </p:nvSpPr>
         <p:spPr>
           <a:xfrm>
-            <a:off x="914400" y="2386584"/>
-            <a:ext cx="2743200" cy="420624"/>
+            <a:off x="914400" y="2272284"/>
+            <a:ext cx="2743200" cy="402336"/>
           </a:xfrm>
           <a:prstGeom prst="rect">
             <a:avLst/>
@@ -31811,8 +31926,8 @@
         </p:nvSpPr>
         <p:spPr>
           <a:xfrm>
-            <a:off x="3749039" y="2386584"/>
-            <a:ext cx="5394960" cy="420624"/>
+            <a:off x="3749039" y="2272284"/>
+            <a:ext cx="5394960" cy="402336"/>
           </a:xfrm>
           <a:prstGeom prst="rect">
             <a:avLst/>
@@ -31859,7 +31974,7 @@
         </p:nvSpPr>
         <p:spPr>
           <a:xfrm>
-            <a:off x="10504424" y="2423160"/>
+            <a:off x="10504424" y="2308860"/>
             <a:ext cx="852424" cy="310896"/>
           </a:xfrm>
           <a:prstGeom prst="roundRect">
@@ -31927,8 +32042,8 @@
         </p:nvSpPr>
         <p:spPr>
           <a:xfrm>
-            <a:off x="713232" y="2907792"/>
-            <a:ext cx="10744200" cy="493776"/>
+            <a:off x="713232" y="2770632"/>
+            <a:ext cx="10744200" cy="457200"/>
           </a:xfrm>
           <a:prstGeom prst="roundRect">
             <a:avLst>
@@ -31973,8 +32088,8 @@
         </p:nvSpPr>
         <p:spPr>
           <a:xfrm>
-            <a:off x="713232" y="2907792"/>
-            <a:ext cx="82296" cy="493776"/>
+            <a:off x="713232" y="2770632"/>
+            <a:ext cx="82296" cy="457200"/>
           </a:xfrm>
           <a:prstGeom prst="rect">
             <a:avLst/>
@@ -32017,8 +32132,8 @@
         </p:nvSpPr>
         <p:spPr>
           <a:xfrm>
-            <a:off x="914400" y="2953512"/>
-            <a:ext cx="2743200" cy="420624"/>
+            <a:off x="914400" y="2807208"/>
+            <a:ext cx="2743200" cy="402336"/>
           </a:xfrm>
           <a:prstGeom prst="rect">
             <a:avLst/>
@@ -32090,8 +32205,8 @@
         </p:nvSpPr>
         <p:spPr>
           <a:xfrm>
-            <a:off x="3749039" y="2953512"/>
-            <a:ext cx="5394960" cy="420624"/>
+            <a:off x="3749039" y="2807208"/>
+            <a:ext cx="5394960" cy="402336"/>
           </a:xfrm>
           <a:prstGeom prst="rect">
             <a:avLst/>
@@ -32138,7 +32253,7 @@
         </p:nvSpPr>
         <p:spPr>
           <a:xfrm>
-            <a:off x="10504424" y="2990088"/>
+            <a:off x="10504424" y="2843784"/>
             <a:ext cx="852424" cy="310896"/>
           </a:xfrm>
           <a:prstGeom prst="roundRect">
@@ -32206,8 +32321,8 @@
         </p:nvSpPr>
         <p:spPr>
           <a:xfrm>
-            <a:off x="713232" y="3474720"/>
-            <a:ext cx="10744200" cy="493776"/>
+            <a:off x="713232" y="3305556"/>
+            <a:ext cx="10744200" cy="457200"/>
           </a:xfrm>
           <a:prstGeom prst="roundRect">
             <a:avLst>
@@ -32252,8 +32367,8 @@
         </p:nvSpPr>
         <p:spPr>
           <a:xfrm>
-            <a:off x="713232" y="3474720"/>
-            <a:ext cx="82296" cy="493776"/>
+            <a:off x="713232" y="3305556"/>
+            <a:ext cx="82296" cy="457200"/>
           </a:xfrm>
           <a:prstGeom prst="rect">
             <a:avLst/>
@@ -32296,8 +32411,8 @@
         </p:nvSpPr>
         <p:spPr>
           <a:xfrm>
-            <a:off x="914400" y="3520440"/>
-            <a:ext cx="2743200" cy="420624"/>
+            <a:off x="914400" y="3342132"/>
+            <a:ext cx="2743200" cy="402336"/>
           </a:xfrm>
           <a:prstGeom prst="rect">
             <a:avLst/>
@@ -32369,8 +32484,8 @@
         </p:nvSpPr>
         <p:spPr>
           <a:xfrm>
-            <a:off x="3749039" y="3520440"/>
-            <a:ext cx="5394960" cy="420624"/>
+            <a:off x="3749039" y="3342132"/>
+            <a:ext cx="5394960" cy="402336"/>
           </a:xfrm>
           <a:prstGeom prst="rect">
             <a:avLst/>
@@ -32417,7 +32532,7 @@
         </p:nvSpPr>
         <p:spPr>
           <a:xfrm>
-            <a:off x="10504424" y="3557016"/>
+            <a:off x="10504424" y="3378708"/>
             <a:ext cx="852424" cy="310896"/>
           </a:xfrm>
           <a:prstGeom prst="roundRect">
@@ -32485,8 +32600,8 @@
         </p:nvSpPr>
         <p:spPr>
           <a:xfrm>
-            <a:off x="713232" y="4041648"/>
-            <a:ext cx="10744200" cy="493776"/>
+            <a:off x="713232" y="3840480"/>
+            <a:ext cx="10744200" cy="457200"/>
           </a:xfrm>
           <a:prstGeom prst="roundRect">
             <a:avLst>
@@ -32531,14 +32646,14 @@
         </p:nvSpPr>
         <p:spPr>
           <a:xfrm>
-            <a:off x="713232" y="4041648"/>
-            <a:ext cx="82296" cy="493776"/>
-          </a:xfrm>
-          <a:prstGeom prst="rect">
-            <a:avLst/>
-          </a:prstGeom>
-          <a:solidFill>
-            <a:srgbClr val="D99A2B"/>
+            <a:off x="713232" y="3840480"/>
+            <a:ext cx="82296" cy="457200"/>
+          </a:xfrm>
+          <a:prstGeom prst="rect">
+            <a:avLst/>
+          </a:prstGeom>
+          <a:solidFill>
+            <a:srgbClr val="2F9E6A"/>
           </a:solidFill>
           <a:ln>
             <a:noFill/>
@@ -32575,8 +32690,8 @@
         </p:nvSpPr>
         <p:spPr>
           <a:xfrm>
-            <a:off x="914400" y="4087368"/>
-            <a:ext cx="2743200" cy="420624"/>
+            <a:off x="914400" y="3877056"/>
+            <a:ext cx="2743200" cy="402336"/>
           </a:xfrm>
           <a:prstGeom prst="rect">
             <a:avLst/>
@@ -32648,8 +32763,8 @@
         </p:nvSpPr>
         <p:spPr>
           <a:xfrm>
-            <a:off x="3749039" y="4087368"/>
-            <a:ext cx="5394960" cy="420624"/>
+            <a:off x="3749039" y="3877056"/>
+            <a:ext cx="5394960" cy="402336"/>
           </a:xfrm>
           <a:prstGeom prst="rect">
             <a:avLst/>
@@ -32696,7 +32811,7 @@
         </p:nvSpPr>
         <p:spPr>
           <a:xfrm>
-            <a:off x="10504424" y="4123944"/>
+            <a:off x="10504424" y="3913632"/>
             <a:ext cx="852424" cy="310896"/>
           </a:xfrm>
           <a:prstGeom prst="roundRect">
@@ -32705,7 +32820,7 @@
             </a:avLst>
           </a:prstGeom>
           <a:solidFill>
-            <a:srgbClr val="D99A2B"/>
+            <a:srgbClr val="2F9E6A"/>
           </a:solidFill>
           <a:ln>
             <a:noFill/>
@@ -32751,7 +32866,7 @@
                 <a:ea typeface="Microsoft JhengHei"/>
                 <a:cs typeface="Microsoft JhengHei"/>
               </a:rPr>
-              <a:t>搜尋佐證</a:t>
+              <a:t>已見原文</a:t>
             </a:r>
           </a:p>
         </p:txBody>
@@ -32764,8 +32879,8 @@
         </p:nvSpPr>
         <p:spPr>
           <a:xfrm>
-            <a:off x="713232" y="4608576"/>
-            <a:ext cx="10744200" cy="493776"/>
+            <a:off x="713232" y="4375404"/>
+            <a:ext cx="10744200" cy="457200"/>
           </a:xfrm>
           <a:prstGeom prst="roundRect">
             <a:avLst>
@@ -32810,14 +32925,14 @@
         </p:nvSpPr>
         <p:spPr>
           <a:xfrm>
-            <a:off x="713232" y="4608576"/>
-            <a:ext cx="82296" cy="493776"/>
-          </a:xfrm>
-          <a:prstGeom prst="rect">
-            <a:avLst/>
-          </a:prstGeom>
-          <a:solidFill>
-            <a:srgbClr val="D99A2B"/>
+            <a:off x="713232" y="4375404"/>
+            <a:ext cx="82296" cy="457200"/>
+          </a:xfrm>
+          <a:prstGeom prst="rect">
+            <a:avLst/>
+          </a:prstGeom>
+          <a:solidFill>
+            <a:srgbClr val="2F9E6A"/>
           </a:solidFill>
           <a:ln>
             <a:noFill/>
@@ -32854,8 +32969,8 @@
         </p:nvSpPr>
         <p:spPr>
           <a:xfrm>
-            <a:off x="914400" y="4654296"/>
-            <a:ext cx="2743200" cy="420624"/>
+            <a:off x="914400" y="4411980"/>
+            <a:ext cx="2743200" cy="402336"/>
           </a:xfrm>
           <a:prstGeom prst="rect">
             <a:avLst/>
@@ -32927,8 +33042,8 @@
         </p:nvSpPr>
         <p:spPr>
           <a:xfrm>
-            <a:off x="3749039" y="4654296"/>
-            <a:ext cx="5394960" cy="420624"/>
+            <a:off x="3749039" y="4411980"/>
+            <a:ext cx="5394960" cy="402336"/>
           </a:xfrm>
           <a:prstGeom prst="rect">
             <a:avLst/>
@@ -32975,7 +33090,7 @@
         </p:nvSpPr>
         <p:spPr>
           <a:xfrm>
-            <a:off x="10504424" y="4690872"/>
+            <a:off x="10504424" y="4448556"/>
             <a:ext cx="852424" cy="310896"/>
           </a:xfrm>
           <a:prstGeom prst="roundRect">
@@ -32984,7 +33099,7 @@
             </a:avLst>
           </a:prstGeom>
           <a:solidFill>
-            <a:srgbClr val="D99A2B"/>
+            <a:srgbClr val="2F9E6A"/>
           </a:solidFill>
           <a:ln>
             <a:noFill/>
@@ -33030,7 +33145,7 @@
                 <a:ea typeface="Microsoft JhengHei"/>
                 <a:cs typeface="Microsoft JhengHei"/>
               </a:rPr>
-              <a:t>搜尋佐證</a:t>
+              <a:t>已見原文</a:t>
             </a:r>
           </a:p>
         </p:txBody>
@@ -33043,8 +33158,8 @@
         </p:nvSpPr>
         <p:spPr>
           <a:xfrm>
-            <a:off x="713232" y="5175504"/>
-            <a:ext cx="10744200" cy="493776"/>
+            <a:off x="713232" y="4910328"/>
+            <a:ext cx="10744200" cy="457200"/>
           </a:xfrm>
           <a:prstGeom prst="roundRect">
             <a:avLst>
@@ -33089,14 +33204,14 @@
         </p:nvSpPr>
         <p:spPr>
           <a:xfrm>
-            <a:off x="713232" y="5175504"/>
-            <a:ext cx="82296" cy="493776"/>
-          </a:xfrm>
-          <a:prstGeom prst="rect">
-            <a:avLst/>
-          </a:prstGeom>
-          <a:solidFill>
-            <a:srgbClr val="D99A2B"/>
+            <a:off x="713232" y="4910328"/>
+            <a:ext cx="82296" cy="457200"/>
+          </a:xfrm>
+          <a:prstGeom prst="rect">
+            <a:avLst/>
+          </a:prstGeom>
+          <a:solidFill>
+            <a:srgbClr val="2F9E6A"/>
           </a:solidFill>
           <a:ln>
             <a:noFill/>
@@ -33133,8 +33248,8 @@
         </p:nvSpPr>
         <p:spPr>
           <a:xfrm>
-            <a:off x="914400" y="5221224"/>
-            <a:ext cx="2743200" cy="420624"/>
+            <a:off x="914400" y="4946904"/>
+            <a:ext cx="2743200" cy="402336"/>
           </a:xfrm>
           <a:prstGeom prst="rect">
             <a:avLst/>
@@ -33206,8 +33321,8 @@
         </p:nvSpPr>
         <p:spPr>
           <a:xfrm>
-            <a:off x="3749039" y="5221224"/>
-            <a:ext cx="5394960" cy="420624"/>
+            <a:off x="3749039" y="4946904"/>
+            <a:ext cx="5394960" cy="402336"/>
           </a:xfrm>
           <a:prstGeom prst="rect">
             <a:avLst/>
@@ -33254,7 +33369,7 @@
         </p:nvSpPr>
         <p:spPr>
           <a:xfrm>
-            <a:off x="10504424" y="5257800"/>
+            <a:off x="10504424" y="4983480"/>
             <a:ext cx="852424" cy="310896"/>
           </a:xfrm>
           <a:prstGeom prst="roundRect">
@@ -33263,7 +33378,7 @@
             </a:avLst>
           </a:prstGeom>
           <a:solidFill>
-            <a:srgbClr val="D99A2B"/>
+            <a:srgbClr val="2F9E6A"/>
           </a:solidFill>
           <a:ln>
             <a:noFill/>
@@ -33309,7 +33424,7 @@
                 <a:ea typeface="Microsoft JhengHei"/>
                 <a:cs typeface="Microsoft JhengHei"/>
               </a:rPr>
-              <a:t>搜尋佐證</a:t>
+              <a:t>已見原文</a:t>
             </a:r>
           </a:p>
         </p:txBody>
@@ -33322,8 +33437,8 @@
         </p:nvSpPr>
         <p:spPr>
           <a:xfrm>
-            <a:off x="713232" y="5742432"/>
-            <a:ext cx="10744200" cy="493776"/>
+            <a:off x="713232" y="5445252"/>
+            <a:ext cx="10744200" cy="457200"/>
           </a:xfrm>
           <a:prstGeom prst="roundRect">
             <a:avLst>
@@ -33368,8 +33483,8 @@
         </p:nvSpPr>
         <p:spPr>
           <a:xfrm>
-            <a:off x="713232" y="5742432"/>
-            <a:ext cx="82296" cy="493776"/>
+            <a:off x="713232" y="5445252"/>
+            <a:ext cx="82296" cy="457200"/>
           </a:xfrm>
           <a:prstGeom prst="rect">
             <a:avLst/>
@@ -33412,8 +33527,8 @@
         </p:nvSpPr>
         <p:spPr>
           <a:xfrm>
-            <a:off x="914400" y="5788152"/>
-            <a:ext cx="2743200" cy="420624"/>
+            <a:off x="914400" y="5481828"/>
+            <a:ext cx="2743200" cy="402336"/>
           </a:xfrm>
           <a:prstGeom prst="rect">
             <a:avLst/>
@@ -33485,8 +33600,8 @@
         </p:nvSpPr>
         <p:spPr>
           <a:xfrm>
-            <a:off x="3749039" y="5788152"/>
-            <a:ext cx="5394960" cy="420624"/>
+            <a:off x="3749039" y="5481828"/>
+            <a:ext cx="5394960" cy="402336"/>
           </a:xfrm>
           <a:prstGeom prst="rect">
             <a:avLst/>
@@ -33533,7 +33648,7 @@
         </p:nvSpPr>
         <p:spPr>
           <a:xfrm>
-            <a:off x="10504424" y="5824728"/>
+            <a:off x="10504424" y="5518404"/>
             <a:ext cx="852424" cy="310896"/>
           </a:xfrm>
           <a:prstGeom prst="roundRect">
@@ -33595,14 +33710,104 @@
       </p:sp>
       <p:sp>
         <p:nvSpPr>
-          <p:cNvPr id="46" name="TextBox 45"/>
+          <p:cNvPr id="46" name="Rounded Rectangle 45"/>
+          <p:cNvSpPr/>
+          <p:nvPr/>
+        </p:nvSpPr>
+        <p:spPr>
+          <a:xfrm>
+            <a:off x="713232" y="5943600"/>
+            <a:ext cx="10744200" cy="731520"/>
+          </a:xfrm>
+          <a:prstGeom prst="roundRect">
+            <a:avLst>
+              <a:gd name="adj" fmla="val 6000"/>
+            </a:avLst>
+          </a:prstGeom>
+          <a:solidFill>
+            <a:srgbClr val="ECF6F0"/>
+          </a:solidFill>
+          <a:ln>
+            <a:noFill/>
+          </a:ln>
+          <a:effectLst/>
+        </p:spPr>
+        <p:style>
+          <a:lnRef idx="1">
+            <a:schemeClr val="accent1"/>
+          </a:lnRef>
+          <a:fillRef idx="3">
+            <a:schemeClr val="accent1"/>
+          </a:fillRef>
+          <a:effectRef idx="2">
+            <a:schemeClr val="accent1"/>
+          </a:effectRef>
+          <a:fontRef idx="minor">
+            <a:schemeClr val="lt1"/>
+          </a:fontRef>
+        </p:style>
+        <p:txBody>
+          <a:bodyPr rtlCol="0" anchor="ctr"/>
+          <a:lstStyle/>
+          <a:p>
+            <a:pPr algn="ctr"/>
+          </a:p>
+        </p:txBody>
+      </p:sp>
+      <p:sp>
+        <p:nvSpPr>
+          <p:cNvPr id="47" name="Rectangle 46"/>
+          <p:cNvSpPr/>
+          <p:nvPr/>
+        </p:nvSpPr>
+        <p:spPr>
+          <a:xfrm>
+            <a:off x="713232" y="5943600"/>
+            <a:ext cx="91440" cy="731520"/>
+          </a:xfrm>
+          <a:prstGeom prst="rect">
+            <a:avLst/>
+          </a:prstGeom>
+          <a:solidFill>
+            <a:srgbClr val="2F9E6A"/>
+          </a:solidFill>
+          <a:ln>
+            <a:noFill/>
+          </a:ln>
+          <a:effectLst/>
+        </p:spPr>
+        <p:style>
+          <a:lnRef idx="1">
+            <a:schemeClr val="accent1"/>
+          </a:lnRef>
+          <a:fillRef idx="3">
+            <a:schemeClr val="accent1"/>
+          </a:fillRef>
+          <a:effectRef idx="2">
+            <a:schemeClr val="accent1"/>
+          </a:effectRef>
+          <a:fontRef idx="minor">
+            <a:schemeClr val="lt1"/>
+          </a:fontRef>
+        </p:style>
+        <p:txBody>
+          <a:bodyPr rtlCol="0" anchor="ctr"/>
+          <a:lstStyle/>
+          <a:p>
+            <a:pPr algn="ctr"/>
+          </a:p>
+        </p:txBody>
+      </p:sp>
+      <p:sp>
+        <p:nvSpPr>
+          <p:cNvPr id="48" name="TextBox 47"/>
           <p:cNvSpPr txBox="1"/>
           <p:nvPr/>
         </p:nvSpPr>
         <p:spPr>
           <a:xfrm>
-            <a:off x="502920" y="6419088"/>
-            <a:ext cx="8686800" cy="274320"/>
+            <a:off x="950976" y="6071616"/>
+            <a:ext cx="10360152" cy="512064"/>
           </a:xfrm>
           <a:prstGeom prst="rect">
             <a:avLst/>
@@ -33628,15 +33833,40 @@
               <a:buNone/>
             </a:pPr>
             <a:r>
-              <a:rPr sz="850" b="0" i="0" lang="zh-TW">
-                <a:solidFill>
-                  <a:srgbClr val="6B7885"/>
-                </a:solidFill>
-                <a:latin typeface="Segoe UI"/>
-                <a:ea typeface="Microsoft JhengHei"/>
-                <a:cs typeface="Microsoft JhengHei"/>
-              </a:rPr>
-              <a:t>低成本設備 × 生命徵象 × 主訴 → 初步檢傷 / 急症判斷</a:t>
+              <a:rPr sz="1150" b="1" i="0" lang="zh-TW">
+                <a:solidFill>
+                  <a:srgbClr val="2F9E6A"/>
+                </a:solidFill>
+                <a:latin typeface="Segoe UI"/>
+                <a:ea typeface="Microsoft JhengHei"/>
+                <a:cs typeface="Microsoft JhengHei"/>
+              </a:rPr>
+              <a:t>已見原文的程式碼來源（GitHub 可存取）</a:t>
+            </a:r>
+          </a:p>
+          <a:p>
+            <a:pPr algn="l">
+              <a:lnSpc>
+                <a:spcPct val="116000"/>
+              </a:lnSpc>
+              <a:spcBef>
+                <a:spcPts val="0"/>
+              </a:spcBef>
+              <a:spcAft>
+                <a:spcPts val="400"/>
+              </a:spcAft>
+              <a:buNone/>
+            </a:pPr>
+            <a:r>
+              <a:rPr sz="1150" b="0" i="0" lang="zh-TW">
+                <a:solidFill>
+                  <a:srgbClr val="33414F"/>
+                </a:solidFill>
+                <a:latin typeface="Segoe UI"/>
+                <a:ea typeface="Microsoft JhengHei"/>
+                <a:cs typeface="Microsoft JhengHei"/>
+              </a:rPr>
+              <a:t>Joseph：github.com/jwjoseph/NN_triage_predict　·　Hannun：github.com/awni/ecg（官方）　·　Hsu：github.com/Yan-Cheng-Hsu/Blood-Pressure-Estimation-Model（官方）　·　Ming：github.com/jsmdaniels/VITAL（官方）　·　Pahar：github.com/raina-akshay/covidfromcough（第三方）</a:t>
             </a:r>
           </a:p>
         </p:txBody>

</xml_diff>